<commit_message>
Adiciona formulário interativo da pesquisa (preview) e mostra a pergunta de Líder Comunicador a qualquer líder
Co-Authored-By: Claude Sonnet 5.5 <noreply@anthropic.com>
Claude-Session: https://claude.ai/code/session_012bAQjcktBYtXDmGDPn1u1a
</commit_message>
<xml_diff>
--- a/pesquisa-comunicacao-de-para/Pesquisa_Comunicacao_DE_PARA.pptx
+++ b/pesquisa-comunicacao-de-para/Pesquisa_Comunicacao_DE_PARA.pptx
@@ -5172,7 +5172,7 @@
                 </a:solidFill>
                 <a:latin typeface="Calibri"/>
               </a:rPr>
-              <a:t>Matriz por canal; cargo e corredor obrigatórios, com as 4 opções exatas</a:t>
+              <a:t>Matriz por canal; posição (líder ou não) e corredor obrigatórios</a:t>
             </a:r>
           </a:p>
         </p:txBody>
@@ -8907,7 +8907,7 @@
                 </a:solidFill>
                 <a:latin typeface="Calibri"/>
               </a:rPr>
-              <a:t>Só supervisores e gerentes: satisfação com cada canal face a face [Impulsiona Líder, Diálogos de Negócio, CCF…].</a:t>
+              <a:t>Só quem lidera pessoas (qualquer cargo): satisfação com cada canal face a face [Impulsiona Líder, Diálogos de Negócio, CCF…].</a:t>
             </a:r>
           </a:p>
         </p:txBody>
@@ -9177,7 +9177,7 @@
                 </a:solidFill>
                 <a:latin typeface="Calibri"/>
               </a:rPr>
-              <a:t>Filtros obrigatórios, não pontuam: corredor (Norte, Leste, Sudeste, Minas Rio/Minas Bahia) e cargo. Opcional: 1 pergunta aberta.</a:t>
+              <a:t>Filtros obrigatórios, não pontuam: corredor (Norte, Leste, Sudeste, Minas Rio/Minas Bahia) e posição (sem equipe, ou líder de qualquer cargo). Opcional: 1 pergunta aberta.</a:t>
             </a:r>
           </a:p>
         </p:txBody>
@@ -10220,7 +10220,7 @@
                 </a:solidFill>
                 <a:latin typeface="Calibri"/>
               </a:rPr>
-              <a:t>Público: supervisores e gerentes. Índice = % de notas 4–5 nos canais face a face (pergunta 7).</a:t>
+              <a:t>Público: líderes de qualquer cargo (a meta cita supervisores e gerentes). Índice = % de notas 4–5 nos canais face a face (pergunta 7).</a:t>
             </a:r>
           </a:p>
         </p:txBody>
@@ -12441,7 +12441,7 @@
                 </a:solidFill>
                 <a:latin typeface="Calibri"/>
               </a:rPr>
-              <a:t> tratar supervisores e gerentes como </a:t>
+              <a:t> tratar os líderes como </a:t>
             </a:r>
             <a:r>
               <a:rPr sz="1162" b="1">
@@ -13295,7 +13295,7 @@
                 </a:solidFill>
                 <a:latin typeface="Calibri"/>
               </a:rPr>
-              <a:t>censo de supervisores e gerentes e acompanhamento diário da taxa de resposta.</a:t>
+              <a:t>censo dos líderes e acompanhamento diário da taxa de resposta.</a:t>
             </a:r>
           </a:p>
         </p:txBody>
@@ -16013,7 +16013,7 @@
                 </a:solidFill>
                 <a:latin typeface="Calibri"/>
               </a:rPr>
-              <a:t>Quais cargos são “Líder Comunicador” (só supervisores e gerentes?)</a:t>
+              <a:t>Meta 2 cita supervisores e gerentes, mas a pergunta 7 vai a qualquer líder: a apuração conta todos os líderes ou só esses cargos?</a:t>
             </a:r>
           </a:p>
         </p:txBody>
@@ -16055,7 +16055,7 @@
                 </a:solidFill>
                 <a:latin typeface="Calibri"/>
               </a:rPr>
-              <a:t>Comunicação Interna</a:t>
+              <a:t>Responsável pela meta</a:t>
             </a:r>
           </a:p>
         </p:txBody>

</xml_diff>

<commit_message>
Adiciona formulário interativo da pesquisa (preview) e mostra a pergunta de Líder Comunicador a qualquer líder (#2)
Claude-Session: https://claude.ai/code/session_012bAQjcktBYtXDmGDPn1u1a

Co-authored-by: Claude <noreply@anthropic.com>
</commit_message>
<xml_diff>
--- a/pesquisa-comunicacao-de-para/Pesquisa_Comunicacao_DE_PARA.pptx
+++ b/pesquisa-comunicacao-de-para/Pesquisa_Comunicacao_DE_PARA.pptx
@@ -5172,7 +5172,7 @@
                 </a:solidFill>
                 <a:latin typeface="Calibri"/>
               </a:rPr>
-              <a:t>Matriz por canal; cargo e corredor obrigatórios, com as 4 opções exatas</a:t>
+              <a:t>Matriz por canal; posição (líder ou não) e corredor obrigatórios</a:t>
             </a:r>
           </a:p>
         </p:txBody>
@@ -8907,7 +8907,7 @@
                 </a:solidFill>
                 <a:latin typeface="Calibri"/>
               </a:rPr>
-              <a:t>Só supervisores e gerentes: satisfação com cada canal face a face [Impulsiona Líder, Diálogos de Negócio, CCF…].</a:t>
+              <a:t>Só quem lidera pessoas (qualquer cargo): satisfação com cada canal face a face [Impulsiona Líder, Diálogos de Negócio, CCF…].</a:t>
             </a:r>
           </a:p>
         </p:txBody>
@@ -9177,7 +9177,7 @@
                 </a:solidFill>
                 <a:latin typeface="Calibri"/>
               </a:rPr>
-              <a:t>Filtros obrigatórios, não pontuam: corredor (Norte, Leste, Sudeste, Minas Rio/Minas Bahia) e cargo. Opcional: 1 pergunta aberta.</a:t>
+              <a:t>Filtros obrigatórios, não pontuam: corredor (Norte, Leste, Sudeste, Minas Rio/Minas Bahia) e posição (sem equipe, ou líder de qualquer cargo). Opcional: 1 pergunta aberta.</a:t>
             </a:r>
           </a:p>
         </p:txBody>
@@ -10220,7 +10220,7 @@
                 </a:solidFill>
                 <a:latin typeface="Calibri"/>
               </a:rPr>
-              <a:t>Público: supervisores e gerentes. Índice = % de notas 4–5 nos canais face a face (pergunta 7).</a:t>
+              <a:t>Público: líderes de qualquer cargo (a meta cita supervisores e gerentes). Índice = % de notas 4–5 nos canais face a face (pergunta 7).</a:t>
             </a:r>
           </a:p>
         </p:txBody>
@@ -12441,7 +12441,7 @@
                 </a:solidFill>
                 <a:latin typeface="Calibri"/>
               </a:rPr>
-              <a:t> tratar supervisores e gerentes como </a:t>
+              <a:t> tratar os líderes como </a:t>
             </a:r>
             <a:r>
               <a:rPr sz="1162" b="1">
@@ -13295,7 +13295,7 @@
                 </a:solidFill>
                 <a:latin typeface="Calibri"/>
               </a:rPr>
-              <a:t>censo de supervisores e gerentes e acompanhamento diário da taxa de resposta.</a:t>
+              <a:t>censo dos líderes e acompanhamento diário da taxa de resposta.</a:t>
             </a:r>
           </a:p>
         </p:txBody>
@@ -16013,7 +16013,7 @@
                 </a:solidFill>
                 <a:latin typeface="Calibri"/>
               </a:rPr>
-              <a:t>Quais cargos são “Líder Comunicador” (só supervisores e gerentes?)</a:t>
+              <a:t>Meta 2 cita supervisores e gerentes, mas a pergunta 7 vai a qualquer líder: a apuração conta todos os líderes ou só esses cargos?</a:t>
             </a:r>
           </a:p>
         </p:txBody>
@@ -16055,7 +16055,7 @@
                 </a:solidFill>
                 <a:latin typeface="Calibri"/>
               </a:rPr>
-              <a:t>Comunicação Interna</a:t>
+              <a:t>Responsável pela meta</a:t>
             </a:r>
           </a:p>
         </p:txBody>

</xml_diff>